<commit_message>
Updated files Hardware testing
</commit_message>
<xml_diff>
--- a/Write Ups/Midway Presentation.pptx
+++ b/Write Ups/Midway Presentation.pptx
@@ -119,6 +119,11 @@
       </a:defRPr>
     </a:lvl9pPr>
   </p:defaultTextStyle>
+  <p:extLst>
+    <p:ext uri="{EFAFB233-063F-42B5-8137-9DF3F51BA10A}">
+      <p15:sldGuideLst xmlns:p15="http://schemas.microsoft.com/office/powerpoint/2012/main"/>
+    </p:ext>
+  </p:extLst>
 </p:presentation>
 </file>
 
@@ -3682,7 +3687,7 @@
           <a:p>
             <a:fld id="{388ED7F3-BDC0-4E01-B727-F7B567EF5B3F}" type="datetimeFigureOut">
               <a:rPr lang="en-IE" smtClean="0"/>
-              <a:t>05/01/2026</a:t>
+              <a:t>14/01/2026</a:t>
             </a:fld>
             <a:endParaRPr lang="en-IE"/>
           </a:p>
@@ -4215,7 +4220,7 @@
           <a:p>
             <a:fld id="{AC2EAE4B-7CCD-44D5-8B66-978E65139741}" type="datetimeFigureOut">
               <a:rPr lang="en-IE" smtClean="0"/>
-              <a:t>05/01/2026</a:t>
+              <a:t>14/01/2026</a:t>
             </a:fld>
             <a:endParaRPr lang="en-IE"/>
           </a:p>
@@ -4415,7 +4420,7 @@
           <a:p>
             <a:fld id="{AC2EAE4B-7CCD-44D5-8B66-978E65139741}" type="datetimeFigureOut">
               <a:rPr lang="en-IE" smtClean="0"/>
-              <a:t>05/01/2026</a:t>
+              <a:t>14/01/2026</a:t>
             </a:fld>
             <a:endParaRPr lang="en-IE"/>
           </a:p>
@@ -4625,7 +4630,7 @@
           <a:p>
             <a:fld id="{AC2EAE4B-7CCD-44D5-8B66-978E65139741}" type="datetimeFigureOut">
               <a:rPr lang="en-IE" smtClean="0"/>
-              <a:t>05/01/2026</a:t>
+              <a:t>14/01/2026</a:t>
             </a:fld>
             <a:endParaRPr lang="en-IE"/>
           </a:p>
@@ -4825,7 +4830,7 @@
           <a:p>
             <a:fld id="{AC2EAE4B-7CCD-44D5-8B66-978E65139741}" type="datetimeFigureOut">
               <a:rPr lang="en-IE" smtClean="0"/>
-              <a:t>05/01/2026</a:t>
+              <a:t>14/01/2026</a:t>
             </a:fld>
             <a:endParaRPr lang="en-IE"/>
           </a:p>
@@ -5101,7 +5106,7 @@
           <a:p>
             <a:fld id="{AC2EAE4B-7CCD-44D5-8B66-978E65139741}" type="datetimeFigureOut">
               <a:rPr lang="en-IE" smtClean="0"/>
-              <a:t>05/01/2026</a:t>
+              <a:t>14/01/2026</a:t>
             </a:fld>
             <a:endParaRPr lang="en-IE"/>
           </a:p>
@@ -5369,7 +5374,7 @@
           <a:p>
             <a:fld id="{AC2EAE4B-7CCD-44D5-8B66-978E65139741}" type="datetimeFigureOut">
               <a:rPr lang="en-IE" smtClean="0"/>
-              <a:t>05/01/2026</a:t>
+              <a:t>14/01/2026</a:t>
             </a:fld>
             <a:endParaRPr lang="en-IE"/>
           </a:p>
@@ -5784,7 +5789,7 @@
           <a:p>
             <a:fld id="{AC2EAE4B-7CCD-44D5-8B66-978E65139741}" type="datetimeFigureOut">
               <a:rPr lang="en-IE" smtClean="0"/>
-              <a:t>05/01/2026</a:t>
+              <a:t>14/01/2026</a:t>
             </a:fld>
             <a:endParaRPr lang="en-IE"/>
           </a:p>
@@ -5926,7 +5931,7 @@
           <a:p>
             <a:fld id="{AC2EAE4B-7CCD-44D5-8B66-978E65139741}" type="datetimeFigureOut">
               <a:rPr lang="en-IE" smtClean="0"/>
-              <a:t>05/01/2026</a:t>
+              <a:t>14/01/2026</a:t>
             </a:fld>
             <a:endParaRPr lang="en-IE"/>
           </a:p>
@@ -6039,7 +6044,7 @@
           <a:p>
             <a:fld id="{AC2EAE4B-7CCD-44D5-8B66-978E65139741}" type="datetimeFigureOut">
               <a:rPr lang="en-IE" smtClean="0"/>
-              <a:t>05/01/2026</a:t>
+              <a:t>14/01/2026</a:t>
             </a:fld>
             <a:endParaRPr lang="en-IE"/>
           </a:p>
@@ -6352,7 +6357,7 @@
           <a:p>
             <a:fld id="{AC2EAE4B-7CCD-44D5-8B66-978E65139741}" type="datetimeFigureOut">
               <a:rPr lang="en-IE" smtClean="0"/>
-              <a:t>05/01/2026</a:t>
+              <a:t>14/01/2026</a:t>
             </a:fld>
             <a:endParaRPr lang="en-IE"/>
           </a:p>
@@ -6641,7 +6646,7 @@
           <a:p>
             <a:fld id="{AC2EAE4B-7CCD-44D5-8B66-978E65139741}" type="datetimeFigureOut">
               <a:rPr lang="en-IE" smtClean="0"/>
-              <a:t>05/01/2026</a:t>
+              <a:t>14/01/2026</a:t>
             </a:fld>
             <a:endParaRPr lang="en-IE"/>
           </a:p>
@@ -6884,7 +6889,7 @@
           <a:p>
             <a:fld id="{AC2EAE4B-7CCD-44D5-8B66-978E65139741}" type="datetimeFigureOut">
               <a:rPr lang="en-IE" smtClean="0"/>
-              <a:t>05/01/2026</a:t>
+              <a:t>14/01/2026</a:t>
             </a:fld>
             <a:endParaRPr lang="en-IE"/>
           </a:p>
@@ -8878,45 +8883,6 @@
           </a:p>
         </p:txBody>
       </p:sp>
-      <p:pic>
-        <p:nvPicPr>
-          <p:cNvPr id="8" name="Picture Placeholder 7">
-            <a:extLst>
-              <a:ext uri="{FF2B5EF4-FFF2-40B4-BE49-F238E27FC236}">
-                <a16:creationId xmlns:a16="http://schemas.microsoft.com/office/drawing/2014/main" id="{28B2E32F-EAB8-0113-14E3-CA27B64892A4}"/>
-              </a:ext>
-            </a:extLst>
-          </p:cNvPr>
-          <p:cNvPicPr>
-            <a:picLocks noGrp="1" noChangeAspect="1"/>
-          </p:cNvPicPr>
-          <p:nvPr>
-            <p:ph type="pic" idx="1"/>
-          </p:nvPr>
-        </p:nvPicPr>
-        <p:blipFill>
-          <a:blip r:embed="rId2">
-            <a:extLst>
-              <a:ext uri="{28A0092B-C50C-407E-A947-70E740481C1C}">
-                <a14:useLocalDpi xmlns:a14="http://schemas.microsoft.com/office/drawing/2010/main" val="0"/>
-              </a:ext>
-            </a:extLst>
-          </a:blip>
-          <a:srcRect l="207" t="-163" r="661" b="163"/>
-          <a:stretch>
-            <a:fillRect/>
-          </a:stretch>
-        </p:blipFill>
-        <p:spPr>
-          <a:xfrm>
-            <a:off x="1046746" y="2676139"/>
-            <a:ext cx="9965250" cy="3895344"/>
-          </a:xfrm>
-          <a:prstGeom prst="rect">
-            <a:avLst/>
-          </a:prstGeom>
-        </p:spPr>
-      </p:pic>
       <p:sp>
         <p:nvSpPr>
           <p:cNvPr id="6" name="AutoShape 4">
@@ -8962,6 +8928,66 @@
           </a:p>
         </p:txBody>
       </p:sp>
+      <p:sp>
+        <p:nvSpPr>
+          <p:cNvPr id="5" name="Picture Placeholder 4">
+            <a:extLst>
+              <a:ext uri="{FF2B5EF4-FFF2-40B4-BE49-F238E27FC236}">
+                <a16:creationId xmlns:a16="http://schemas.microsoft.com/office/drawing/2014/main" id="{F8FCC985-7F65-FA3A-6427-40C4C7BB0CFE}"/>
+              </a:ext>
+            </a:extLst>
+          </p:cNvPr>
+          <p:cNvSpPr>
+            <a:spLocks noGrp="1"/>
+          </p:cNvSpPr>
+          <p:nvPr>
+            <p:ph type="pic" idx="1"/>
+          </p:nvPr>
+        </p:nvSpPr>
+        <p:spPr/>
+        <p:txBody>
+          <a:bodyPr/>
+          <a:lstStyle/>
+          <a:p>
+            <a:endParaRPr lang="en-IE"/>
+          </a:p>
+        </p:txBody>
+      </p:sp>
+      <p:pic>
+        <p:nvPicPr>
+          <p:cNvPr id="7" name="Picture 6">
+            <a:extLst>
+              <a:ext uri="{FF2B5EF4-FFF2-40B4-BE49-F238E27FC236}">
+                <a16:creationId xmlns:a16="http://schemas.microsoft.com/office/drawing/2014/main" id="{8BA9E2E7-3D0B-5939-0689-23CDA9459C39}"/>
+              </a:ext>
+            </a:extLst>
+          </p:cNvPr>
+          <p:cNvPicPr>
+            <a:picLocks noChangeAspect="1"/>
+          </p:cNvPicPr>
+          <p:nvPr/>
+        </p:nvPicPr>
+        <p:blipFill>
+          <a:blip r:embed="rId2">
+            <a:extLst>
+              <a:ext uri="{28A0092B-C50C-407E-A947-70E740481C1C}">
+                <a14:useLocalDpi xmlns:a14="http://schemas.microsoft.com/office/drawing/2010/main" val="0"/>
+              </a:ext>
+            </a:extLst>
+          </a:blip>
+          <a:srcRect t="480" b="480"/>
+          <a:stretch/>
+        </p:blipFill>
+        <p:spPr>
+          <a:xfrm>
+            <a:off x="1978955" y="2387383"/>
+            <a:ext cx="7742561" cy="4032351"/>
+          </a:xfrm>
+          <a:prstGeom prst="rect">
+            <a:avLst/>
+          </a:prstGeom>
+        </p:spPr>
+      </p:pic>
     </p:spTree>
     <p:extLst>
       <p:ext uri="{BB962C8B-B14F-4D97-AF65-F5344CB8AC3E}">

</xml_diff>